<commit_message>
Removed topic-related icons from sheets so as not to bias participants (feedback from Astrid)
</commit_message>
<xml_diff>
--- a/World Cafe Facilitation Guide/Station Topics.pptx
+++ b/World Cafe Facilitation Guide/Station Topics.pptx
@@ -1816,30 +1816,6 @@
           </a:p>
         </p:txBody>
       </p:sp>
-      <p:pic>
-        <p:nvPicPr>
-          <p:cNvPr id="9" name="Image 0" descr="preencoded.png"/>
-          <p:cNvPicPr>
-            <a:picLocks noChangeAspect="1"/>
-          </p:cNvPicPr>
-          <p:nvPr/>
-        </p:nvPicPr>
-        <p:blipFill>
-          <a:blip r:embed="rId3"/>
-          <a:stretch>
-            <a:fillRect/>
-          </a:stretch>
-        </p:blipFill>
-        <p:spPr>
-          <a:xfrm>
-            <a:off x="1993392" y="4251960"/>
-            <a:ext cx="768096" cy="768096"/>
-          </a:xfrm>
-          <a:prstGeom prst="rect">
-            <a:avLst/>
-          </a:prstGeom>
-        </p:spPr>
-      </p:pic>
       <p:sp>
         <p:nvSpPr>
           <p:cNvPr id="10" name="Text 7"/>
@@ -2001,7 +1977,7 @@
           <p:nvPr/>
         </p:nvPicPr>
         <p:blipFill>
-          <a:blip r:embed="rId4"/>
+          <a:blip r:embed="rId3"/>
           <a:stretch>
             <a:fillRect/>
           </a:stretch>
@@ -2099,7 +2075,7 @@
           <p:nvPr/>
         </p:nvPicPr>
         <p:blipFill>
-          <a:blip r:embed="rId5"/>
+          <a:blip r:embed="rId4"/>
           <a:stretch>
             <a:fillRect/>
           </a:stretch>
@@ -2197,7 +2173,7 @@
           <p:nvPr/>
         </p:nvPicPr>
         <p:blipFill>
-          <a:blip r:embed="rId6"/>
+          <a:blip r:embed="rId5"/>
           <a:stretch>
             <a:fillRect/>
           </a:stretch>
@@ -2295,7 +2271,7 @@
           <p:nvPr/>
         </p:nvPicPr>
         <p:blipFill>
-          <a:blip r:embed="rId7"/>
+          <a:blip r:embed="rId6"/>
           <a:stretch>
             <a:fillRect/>
           </a:stretch>
@@ -2658,30 +2634,6 @@
           </a:p>
         </p:txBody>
       </p:sp>
-      <p:pic>
-        <p:nvPicPr>
-          <p:cNvPr id="9" name="Image 0" descr="preencoded.png"/>
-          <p:cNvPicPr>
-            <a:picLocks noChangeAspect="1"/>
-          </p:cNvPicPr>
-          <p:nvPr/>
-        </p:nvPicPr>
-        <p:blipFill>
-          <a:blip r:embed="rId3"/>
-          <a:stretch>
-            <a:fillRect/>
-          </a:stretch>
-        </p:blipFill>
-        <p:spPr>
-          <a:xfrm>
-            <a:off x="1993392" y="4251960"/>
-            <a:ext cx="768096" cy="768096"/>
-          </a:xfrm>
-          <a:prstGeom prst="rect">
-            <a:avLst/>
-          </a:prstGeom>
-        </p:spPr>
-      </p:pic>
       <p:sp>
         <p:nvSpPr>
           <p:cNvPr id="10" name="Text 7"/>
@@ -2843,7 +2795,7 @@
           <p:nvPr/>
         </p:nvPicPr>
         <p:blipFill>
-          <a:blip r:embed="rId4"/>
+          <a:blip r:embed="rId3"/>
           <a:stretch>
             <a:fillRect/>
           </a:stretch>
@@ -2941,7 +2893,7 @@
           <p:nvPr/>
         </p:nvPicPr>
         <p:blipFill>
-          <a:blip r:embed="rId5"/>
+          <a:blip r:embed="rId4"/>
           <a:stretch>
             <a:fillRect/>
           </a:stretch>
@@ -3039,7 +2991,7 @@
           <p:nvPr/>
         </p:nvPicPr>
         <p:blipFill>
-          <a:blip r:embed="rId6"/>
+          <a:blip r:embed="rId5"/>
           <a:stretch>
             <a:fillRect/>
           </a:stretch>
@@ -3137,7 +3089,7 @@
           <p:nvPr/>
         </p:nvPicPr>
         <p:blipFill>
-          <a:blip r:embed="rId7"/>
+          <a:blip r:embed="rId6"/>
           <a:stretch>
             <a:fillRect/>
           </a:stretch>
@@ -3500,30 +3452,6 @@
           </a:p>
         </p:txBody>
       </p:sp>
-      <p:pic>
-        <p:nvPicPr>
-          <p:cNvPr id="9" name="Image 0" descr="preencoded.png"/>
-          <p:cNvPicPr>
-            <a:picLocks noChangeAspect="1"/>
-          </p:cNvPicPr>
-          <p:nvPr/>
-        </p:nvPicPr>
-        <p:blipFill>
-          <a:blip r:embed="rId3"/>
-          <a:stretch>
-            <a:fillRect/>
-          </a:stretch>
-        </p:blipFill>
-        <p:spPr>
-          <a:xfrm>
-            <a:off x="1993392" y="4251960"/>
-            <a:ext cx="768096" cy="768096"/>
-          </a:xfrm>
-          <a:prstGeom prst="rect">
-            <a:avLst/>
-          </a:prstGeom>
-        </p:spPr>
-      </p:pic>
       <p:sp>
         <p:nvSpPr>
           <p:cNvPr id="10" name="Text 7"/>
@@ -3685,7 +3613,7 @@
           <p:nvPr/>
         </p:nvPicPr>
         <p:blipFill>
-          <a:blip r:embed="rId4"/>
+          <a:blip r:embed="rId3"/>
           <a:stretch>
             <a:fillRect/>
           </a:stretch>
@@ -3783,7 +3711,7 @@
           <p:nvPr/>
         </p:nvPicPr>
         <p:blipFill>
-          <a:blip r:embed="rId5"/>
+          <a:blip r:embed="rId4"/>
           <a:stretch>
             <a:fillRect/>
           </a:stretch>
@@ -3881,7 +3809,7 @@
           <p:nvPr/>
         </p:nvPicPr>
         <p:blipFill>
-          <a:blip r:embed="rId6"/>
+          <a:blip r:embed="rId5"/>
           <a:stretch>
             <a:fillRect/>
           </a:stretch>
@@ -3979,7 +3907,7 @@
           <p:nvPr/>
         </p:nvPicPr>
         <p:blipFill>
-          <a:blip r:embed="rId7"/>
+          <a:blip r:embed="rId6"/>
           <a:stretch>
             <a:fillRect/>
           </a:stretch>
@@ -4342,30 +4270,6 @@
           </a:p>
         </p:txBody>
       </p:sp>
-      <p:pic>
-        <p:nvPicPr>
-          <p:cNvPr id="9" name="Image 0" descr="preencoded.png"/>
-          <p:cNvPicPr>
-            <a:picLocks noChangeAspect="1"/>
-          </p:cNvPicPr>
-          <p:nvPr/>
-        </p:nvPicPr>
-        <p:blipFill>
-          <a:blip r:embed="rId3"/>
-          <a:stretch>
-            <a:fillRect/>
-          </a:stretch>
-        </p:blipFill>
-        <p:spPr>
-          <a:xfrm>
-            <a:off x="1993392" y="4251960"/>
-            <a:ext cx="768096" cy="768096"/>
-          </a:xfrm>
-          <a:prstGeom prst="rect">
-            <a:avLst/>
-          </a:prstGeom>
-        </p:spPr>
-      </p:pic>
       <p:sp>
         <p:nvSpPr>
           <p:cNvPr id="10" name="Text 7"/>
@@ -4527,7 +4431,7 @@
           <p:nvPr/>
         </p:nvPicPr>
         <p:blipFill>
-          <a:blip r:embed="rId4"/>
+          <a:blip r:embed="rId3"/>
           <a:stretch>
             <a:fillRect/>
           </a:stretch>
@@ -4625,7 +4529,7 @@
           <p:nvPr/>
         </p:nvPicPr>
         <p:blipFill>
-          <a:blip r:embed="rId5"/>
+          <a:blip r:embed="rId4"/>
           <a:stretch>
             <a:fillRect/>
           </a:stretch>
@@ -4723,7 +4627,7 @@
           <p:nvPr/>
         </p:nvPicPr>
         <p:blipFill>
-          <a:blip r:embed="rId6"/>
+          <a:blip r:embed="rId5"/>
           <a:stretch>
             <a:fillRect/>
           </a:stretch>
@@ -4821,7 +4725,7 @@
           <p:nvPr/>
         </p:nvPicPr>
         <p:blipFill>
-          <a:blip r:embed="rId7"/>
+          <a:blip r:embed="rId6"/>
           <a:stretch>
             <a:fillRect/>
           </a:stretch>
@@ -5184,30 +5088,6 @@
           </a:p>
         </p:txBody>
       </p:sp>
-      <p:pic>
-        <p:nvPicPr>
-          <p:cNvPr id="9" name="Image 0" descr="preencoded.png"/>
-          <p:cNvPicPr>
-            <a:picLocks noChangeAspect="1"/>
-          </p:cNvPicPr>
-          <p:nvPr/>
-        </p:nvPicPr>
-        <p:blipFill>
-          <a:blip r:embed="rId3"/>
-          <a:stretch>
-            <a:fillRect/>
-          </a:stretch>
-        </p:blipFill>
-        <p:spPr>
-          <a:xfrm>
-            <a:off x="1993392" y="4251960"/>
-            <a:ext cx="768096" cy="768096"/>
-          </a:xfrm>
-          <a:prstGeom prst="rect">
-            <a:avLst/>
-          </a:prstGeom>
-        </p:spPr>
-      </p:pic>
       <p:sp>
         <p:nvSpPr>
           <p:cNvPr id="10" name="Text 7"/>
@@ -5390,7 +5270,7 @@
           <p:nvPr/>
         </p:nvPicPr>
         <p:blipFill>
-          <a:blip r:embed="rId4"/>
+          <a:blip r:embed="rId3"/>
           <a:stretch>
             <a:fillRect/>
           </a:stretch>
@@ -5488,7 +5368,7 @@
           <p:nvPr/>
         </p:nvPicPr>
         <p:blipFill>
-          <a:blip r:embed="rId5"/>
+          <a:blip r:embed="rId4"/>
           <a:stretch>
             <a:fillRect/>
           </a:stretch>
@@ -5586,7 +5466,7 @@
           <p:nvPr/>
         </p:nvPicPr>
         <p:blipFill>
-          <a:blip r:embed="rId6"/>
+          <a:blip r:embed="rId5"/>
           <a:stretch>
             <a:fillRect/>
           </a:stretch>
@@ -5684,7 +5564,7 @@
           <p:nvPr/>
         </p:nvPicPr>
         <p:blipFill>
-          <a:blip r:embed="rId7"/>
+          <a:blip r:embed="rId6"/>
           <a:stretch>
             <a:fillRect/>
           </a:stretch>

</xml_diff>

<commit_message>
station topics now human-centered (and sometimes responsible), but not effective. this avoids too many concepts
</commit_message>
<xml_diff>
--- a/World Cafe Facilitation Guide/Station Topics.pptx
+++ b/World Cafe Facilitation Guide/Station Topics.pptx
@@ -3527,7 +3527,7 @@
                 <a:ea typeface="Sora" pitchFamily="34" charset="-122"/>
                 <a:cs typeface="Sora" pitchFamily="34" charset="-120"/>
               </a:rPr>
-              <a:t>What are examples in your organization where the use of AI was not human-centered, not responsible or not effective, or where could you see it easily sliding down that path?</a:t>
+              <a:t>What are examples in your organization where the use of AI was not human-centered, or where could you see it easily sliding down that path?</a:t>
             </a:r>
             <a:endParaRPr lang="en-US" sz="2700" dirty="0"/>
           </a:p>
@@ -4345,7 +4345,7 @@
                 <a:ea typeface="Sora" pitchFamily="34" charset="-122"/>
                 <a:cs typeface="Sora" pitchFamily="34" charset="-120"/>
               </a:rPr>
-              <a:t>What procedures, rules or processes should be implemented to ensure responsible, human-centered AI use in your organization?</a:t>
+              <a:t>What procedures, rules or processes should be implemented to ensure responsible, human-centered AI in your organization?</a:t>
             </a:r>
             <a:endParaRPr lang="en-US" sz="2700" dirty="0"/>
           </a:p>

</xml_diff>

<commit_message>
Removed "responsibly", focused on "human-centered". Improved prompt 2 (was a bit hard to understand)
</commit_message>
<xml_diff>
--- a/World Cafe Facilitation Guide/Station Topics.pptx
+++ b/World Cafe Facilitation Guide/Station Topics.pptx
@@ -1415,7 +1415,7 @@
                 <a:ea typeface="Sora" pitchFamily="34" charset="-122"/>
                 <a:cs typeface="Sora" pitchFamily="34" charset="-120"/>
               </a:rPr>
-              <a:t>AI in Organizations</a:t>
+              <a:t>Human-Centered AI</a:t>
             </a:r>
             <a:endParaRPr lang="en-US" sz="5200" dirty="0"/>
           </a:p>
@@ -1454,7 +1454,7 @@
                 <a:ea typeface="Inter" pitchFamily="34" charset="-122"/>
                 <a:cs typeface="Inter" pitchFamily="34" charset="-120"/>
               </a:rPr>
-              <a:t>A five-station reflexive workshop on responsible, human-centered AI</a:t>
+              <a:t>A five-station reflexive workshop on human-centered AI in organizations</a:t>
             </a:r>
             <a:endParaRPr lang="en-US" sz="1800" dirty="0"/>
           </a:p>
@@ -1891,7 +1891,7 @@
                 <a:ea typeface="Sora" pitchFamily="34" charset="-122"/>
                 <a:cs typeface="Sora" pitchFamily="34" charset="-120"/>
               </a:rPr>
-              <a:t>What should "human-centered AI" look like in your organization? What results or outcomes would you see? What do you hear people say or ask regarding AI?</a:t>
+              <a:t>What should human-centered AI look like in your organization? What results or outcomes would you see? What do you hear people say or ask regarding AI?</a:t>
             </a:r>
             <a:endParaRPr lang="en-US" sz="2700" dirty="0"/>
           </a:p>
@@ -2709,7 +2709,7 @@
                 <a:ea typeface="Sora" pitchFamily="34" charset="-122"/>
                 <a:cs typeface="Sora" pitchFamily="34" charset="-120"/>
               </a:rPr>
-              <a:t>Under what conditions has AI been used in your organization in a manner that supported people?</a:t>
+              <a:t>How has AI been used in your organization in a manner that improved the work experience or work enjoyment of employees?</a:t>
             </a:r>
             <a:endParaRPr lang="en-US" sz="2700" dirty="0"/>
           </a:p>
@@ -4345,7 +4345,7 @@
                 <a:ea typeface="Sora" pitchFamily="34" charset="-122"/>
                 <a:cs typeface="Sora" pitchFamily="34" charset="-120"/>
               </a:rPr>
-              <a:t>What procedures, rules or processes should be implemented to ensure responsible, human-centered AI in your organization?</a:t>
+              <a:t>What procedures, rules or processes should be implemented to ensure  human-centered AI in your organization?</a:t>
             </a:r>
             <a:endParaRPr lang="en-US" sz="2700" dirty="0"/>
           </a:p>
@@ -5184,7 +5184,7 @@
                 <a:ea typeface="Sora" pitchFamily="34" charset="-122"/>
                 <a:cs typeface="Sora" pitchFamily="34" charset="-120"/>
               </a:rPr>
-              <a:t>audited to ensure that the way your organization uses AI is responsible and human-centered?</a:t>
+              <a:t>audited to ensure that the way your organization uses AI is human-centered?</a:t>
             </a:r>
             <a:endParaRPr lang="en-US" sz="2700" dirty="0"/>
           </a:p>

</xml_diff>